<commit_message>
feat: refresh keynote landscape experience
</commit_message>
<xml_diff>
--- a/insights/260807-CoC-KN/awesome-agentic-landscape/awesome_agentic_landscape_one_slide_2026.pptx
+++ b/insights/260807-CoC-KN/awesome-agentic-landscape/awesome_agentic_landscape_one_slide_2026.pptx
@@ -2,13 +2,13 @@
 <file path=ppt/presentation.xml><?xml version="1.0" encoding="utf-8"?>
 <p:presentation xmlns:p="http://schemas.openxmlformats.org/presentationml/2006/main">
   <p:sldMasterIdLst>
-    <p:sldMasterId xmlns:r="http://schemas.openxmlformats.org/officeDocument/2006/relationships" id="2147483648" r:id="Rd9d2b500d1ae4da8"/>
+    <p:sldMasterId xmlns:r="http://schemas.openxmlformats.org/officeDocument/2006/relationships" id="2147483648" r:id="R1c3b589831e945bc"/>
   </p:sldMasterIdLst>
   <p:notesMasterIdLst>
-    <p:notesMasterId xmlns:r="http://schemas.openxmlformats.org/officeDocument/2006/relationships" r:id="Rb9f1b8123df24b80"/>
+    <p:notesMasterId xmlns:r="http://schemas.openxmlformats.org/officeDocument/2006/relationships" r:id="R5dd1926e2eab47b0"/>
   </p:notesMasterIdLst>
   <p:sldIdLst>
-    <p:sldId xmlns:r="http://schemas.openxmlformats.org/officeDocument/2006/relationships" id="256" r:id="Rbc897a353c9c4f03"/>
+    <p:sldId xmlns:r="http://schemas.openxmlformats.org/officeDocument/2006/relationships" id="256" r:id="R7213964093464045"/>
   </p:sldIdLst>
   <p:sldSz cx="12192000" cy="6858000"/>
   <p:notesSz cx="6858000" cy="9144000"/>
@@ -200,14 +200,14 @@
     </a:clrScheme>
     <a:fontScheme name="Office">
       <a:majorFont>
-        <a:latin typeface="Calibri Light"/>
-        <a:ea typeface="Calibri Light"/>
-        <a:cs typeface="Calibri Light"/>
+        <a:latin typeface="Alibaba PuHuiTi"/>
+        <a:ea typeface="Alibaba PuHuiTi"/>
+        <a:cs typeface="Alibaba PuHuiTi"/>
       </a:majorFont>
       <a:minorFont>
-        <a:latin typeface="Calibri"/>
-        <a:ea typeface="Calibri"/>
-        <a:cs typeface="Calibri"/>
+        <a:latin typeface="Alibaba PuHuiTi"/>
+        <a:ea typeface="Alibaba PuHuiTi"/>
+        <a:cs typeface="Alibaba PuHuiTi"/>
       </a:minorFont>
     </a:fontScheme>
     <a:fmtScheme name="ChatGPT">
@@ -580,7 +580,7 @@
   </p:cSld>
   <p:clrMap bg1="lt1" tx1="dk1" bg2="lt2" tx2="dk2" accent1="accent1" accent2="accent2" accent3="accent3" accent4="accent4" accent5="accent5" accent6="accent6" hlink="hlink" folHlink="folHlink"/>
   <p:sldLayoutIdLst>
-    <p:sldLayoutId xmlns:r="http://schemas.openxmlformats.org/officeDocument/2006/relationships" id="2147483649" r:id="R847fa9a791204818"/>
+    <p:sldLayoutId xmlns:r="http://schemas.openxmlformats.org/officeDocument/2006/relationships" id="2147483649" r:id="Rb6df104784304ec7"/>
   </p:sldLayoutIdLst>
   <p:txStyles>
     <p:titleStyle>
@@ -596,9 +596,9 @@
           <a:solidFill>
             <a:schemeClr val="tx1"/>
           </a:solidFill>
-          <a:latin typeface="+mj-lt"/>
-          <a:ea typeface="+mj-lt"/>
-          <a:cs typeface="+mj-lt"/>
+          <a:latin typeface="Alibaba PuHuiTi"/>
+          <a:ea typeface="Alibaba PuHuiTi"/>
+          <a:cs typeface="Alibaba PuHuiTi"/>
         </a:defRPr>
       </a:lvl1pPr>
     </p:titleStyle>
@@ -615,9 +615,9 @@
           <a:solidFill>
             <a:schemeClr val="tx1"/>
           </a:solidFill>
-          <a:latin typeface="+mn-lt"/>
-          <a:ea typeface="+mn-lt"/>
-          <a:cs typeface="+mn-lt"/>
+          <a:latin typeface="Alibaba PuHuiTi"/>
+          <a:ea typeface="Alibaba PuHuiTi"/>
+          <a:cs typeface="Alibaba PuHuiTi"/>
         </a:defRPr>
       </a:lvl1pPr>
       <a:lvl2pPr xmlns:a="http://schemas.openxmlformats.org/drawingml/2006/main" marL="685800" indent="-228600" algn="l">
@@ -632,9 +632,9 @@
           <a:solidFill>
             <a:schemeClr val="tx1"/>
           </a:solidFill>
-          <a:latin typeface="+mn-lt"/>
-          <a:ea typeface="+mn-lt"/>
-          <a:cs typeface="+mn-lt"/>
+          <a:latin typeface="Alibaba PuHuiTi"/>
+          <a:ea typeface="Alibaba PuHuiTi"/>
+          <a:cs typeface="Alibaba PuHuiTi"/>
         </a:defRPr>
       </a:lvl2pPr>
       <a:lvl3pPr xmlns:a="http://schemas.openxmlformats.org/drawingml/2006/main" marL="1143000" indent="-228600" algn="l">
@@ -649,9 +649,9 @@
           <a:solidFill>
             <a:schemeClr val="tx1"/>
           </a:solidFill>
-          <a:latin typeface="+mn-lt"/>
-          <a:ea typeface="+mn-lt"/>
-          <a:cs typeface="+mn-lt"/>
+          <a:latin typeface="Alibaba PuHuiTi"/>
+          <a:ea typeface="Alibaba PuHuiTi"/>
+          <a:cs typeface="Alibaba PuHuiTi"/>
         </a:defRPr>
       </a:lvl3pPr>
       <a:lvl4pPr xmlns:a="http://schemas.openxmlformats.org/drawingml/2006/main" marL="1600200" indent="-228600" algn="l">
@@ -666,9 +666,9 @@
           <a:solidFill>
             <a:schemeClr val="tx1"/>
           </a:solidFill>
-          <a:latin typeface="+mn-lt"/>
-          <a:ea typeface="+mn-lt"/>
-          <a:cs typeface="+mn-lt"/>
+          <a:latin typeface="Alibaba PuHuiTi"/>
+          <a:ea typeface="Alibaba PuHuiTi"/>
+          <a:cs typeface="Alibaba PuHuiTi"/>
         </a:defRPr>
       </a:lvl4pPr>
       <a:lvl5pPr xmlns:a="http://schemas.openxmlformats.org/drawingml/2006/main" marL="2057400" indent="-228600" algn="l">
@@ -683,9 +683,9 @@
           <a:solidFill>
             <a:schemeClr val="tx1"/>
           </a:solidFill>
-          <a:latin typeface="+mn-lt"/>
-          <a:ea typeface="+mn-lt"/>
-          <a:cs typeface="+mn-lt"/>
+          <a:latin typeface="Alibaba PuHuiTi"/>
+          <a:ea typeface="Alibaba PuHuiTi"/>
+          <a:cs typeface="Alibaba PuHuiTi"/>
         </a:defRPr>
       </a:lvl5pPr>
       <a:lvl6pPr xmlns:a="http://schemas.openxmlformats.org/drawingml/2006/main" marL="2514600" indent="-228600" algn="l">
@@ -700,9 +700,9 @@
           <a:solidFill>
             <a:schemeClr val="tx1"/>
           </a:solidFill>
-          <a:latin typeface="+mn-lt"/>
-          <a:ea typeface="+mn-lt"/>
-          <a:cs typeface="+mn-lt"/>
+          <a:latin typeface="Alibaba PuHuiTi"/>
+          <a:ea typeface="Alibaba PuHuiTi"/>
+          <a:cs typeface="Alibaba PuHuiTi"/>
         </a:defRPr>
       </a:lvl6pPr>
       <a:lvl7pPr xmlns:a="http://schemas.openxmlformats.org/drawingml/2006/main" marL="2971800" indent="-228600" algn="l">
@@ -717,9 +717,9 @@
           <a:solidFill>
             <a:schemeClr val="tx1"/>
           </a:solidFill>
-          <a:latin typeface="+mn-lt"/>
-          <a:ea typeface="+mn-lt"/>
-          <a:cs typeface="+mn-lt"/>
+          <a:latin typeface="Alibaba PuHuiTi"/>
+          <a:ea typeface="Alibaba PuHuiTi"/>
+          <a:cs typeface="Alibaba PuHuiTi"/>
         </a:defRPr>
       </a:lvl7pPr>
       <a:lvl8pPr xmlns:a="http://schemas.openxmlformats.org/drawingml/2006/main" marL="3429000" indent="-228600" algn="l">
@@ -734,9 +734,9 @@
           <a:solidFill>
             <a:schemeClr val="tx1"/>
           </a:solidFill>
-          <a:latin typeface="+mn-lt"/>
-          <a:ea typeface="+mn-lt"/>
-          <a:cs typeface="+mn-lt"/>
+          <a:latin typeface="Alibaba PuHuiTi"/>
+          <a:ea typeface="Alibaba PuHuiTi"/>
+          <a:cs typeface="Alibaba PuHuiTi"/>
         </a:defRPr>
       </a:lvl8pPr>
       <a:lvl9pPr xmlns:a="http://schemas.openxmlformats.org/drawingml/2006/main" marL="3886200" indent="-228600" algn="l">
@@ -751,9 +751,9 @@
           <a:solidFill>
             <a:schemeClr val="tx1"/>
           </a:solidFill>
-          <a:latin typeface="+mn-lt"/>
-          <a:ea typeface="+mn-lt"/>
-          <a:cs typeface="+mn-lt"/>
+          <a:latin typeface="Alibaba PuHuiTi"/>
+          <a:ea typeface="Alibaba PuHuiTi"/>
+          <a:cs typeface="Alibaba PuHuiTi"/>
         </a:defRPr>
       </a:lvl9pPr>
     </p:bodyStyle>
@@ -764,9 +764,9 @@
           <a:solidFill>
             <a:schemeClr val="tx1"/>
           </a:solidFill>
-          <a:latin typeface="+mn-lt"/>
-          <a:ea typeface="+mn-lt"/>
-          <a:cs typeface="+mn-lt"/>
+          <a:latin typeface="Alibaba PuHuiTi"/>
+          <a:ea typeface="Alibaba PuHuiTi"/>
+          <a:cs typeface="Alibaba PuHuiTi"/>
         </a:defRPr>
       </a:lvl1pPr>
       <a:lvl2pPr xmlns:a="http://schemas.openxmlformats.org/drawingml/2006/main" marL="457200" algn="l">
@@ -775,9 +775,9 @@
           <a:solidFill>
             <a:schemeClr val="tx1"/>
           </a:solidFill>
-          <a:latin typeface="+mn-lt"/>
-          <a:ea typeface="+mn-lt"/>
-          <a:cs typeface="+mn-lt"/>
+          <a:latin typeface="Alibaba PuHuiTi"/>
+          <a:ea typeface="Alibaba PuHuiTi"/>
+          <a:cs typeface="Alibaba PuHuiTi"/>
         </a:defRPr>
       </a:lvl2pPr>
       <a:lvl3pPr xmlns:a="http://schemas.openxmlformats.org/drawingml/2006/main" marL="914400" algn="l">
@@ -786,9 +786,9 @@
           <a:solidFill>
             <a:schemeClr val="tx1"/>
           </a:solidFill>
-          <a:latin typeface="+mn-lt"/>
-          <a:ea typeface="+mn-lt"/>
-          <a:cs typeface="+mn-lt"/>
+          <a:latin typeface="Alibaba PuHuiTi"/>
+          <a:ea typeface="Alibaba PuHuiTi"/>
+          <a:cs typeface="Alibaba PuHuiTi"/>
         </a:defRPr>
       </a:lvl3pPr>
       <a:lvl4pPr xmlns:a="http://schemas.openxmlformats.org/drawingml/2006/main" marL="1371600" algn="l">
@@ -797,9 +797,9 @@
           <a:solidFill>
             <a:schemeClr val="tx1"/>
           </a:solidFill>
-          <a:latin typeface="+mn-lt"/>
-          <a:ea typeface="+mn-lt"/>
-          <a:cs typeface="+mn-lt"/>
+          <a:latin typeface="Alibaba PuHuiTi"/>
+          <a:ea typeface="Alibaba PuHuiTi"/>
+          <a:cs typeface="Alibaba PuHuiTi"/>
         </a:defRPr>
       </a:lvl4pPr>
       <a:lvl5pPr xmlns:a="http://schemas.openxmlformats.org/drawingml/2006/main" marL="1828800" algn="l">
@@ -808,9 +808,9 @@
           <a:solidFill>
             <a:schemeClr val="tx1"/>
           </a:solidFill>
-          <a:latin typeface="+mn-lt"/>
-          <a:ea typeface="+mn-lt"/>
-          <a:cs typeface="+mn-lt"/>
+          <a:latin typeface="Alibaba PuHuiTi"/>
+          <a:ea typeface="Alibaba PuHuiTi"/>
+          <a:cs typeface="Alibaba PuHuiTi"/>
         </a:defRPr>
       </a:lvl5pPr>
       <a:lvl6pPr xmlns:a="http://schemas.openxmlformats.org/drawingml/2006/main" marL="2286000" algn="l">
@@ -819,9 +819,9 @@
           <a:solidFill>
             <a:schemeClr val="tx1"/>
           </a:solidFill>
-          <a:latin typeface="+mn-lt"/>
-          <a:ea typeface="+mn-lt"/>
-          <a:cs typeface="+mn-lt"/>
+          <a:latin typeface="Alibaba PuHuiTi"/>
+          <a:ea typeface="Alibaba PuHuiTi"/>
+          <a:cs typeface="Alibaba PuHuiTi"/>
         </a:defRPr>
       </a:lvl6pPr>
       <a:lvl7pPr xmlns:a="http://schemas.openxmlformats.org/drawingml/2006/main" marL="2743200" algn="l">
@@ -830,9 +830,9 @@
           <a:solidFill>
             <a:schemeClr val="tx1"/>
           </a:solidFill>
-          <a:latin typeface="+mn-lt"/>
-          <a:ea typeface="+mn-lt"/>
-          <a:cs typeface="+mn-lt"/>
+          <a:latin typeface="Alibaba PuHuiTi"/>
+          <a:ea typeface="Alibaba PuHuiTi"/>
+          <a:cs typeface="Alibaba PuHuiTi"/>
         </a:defRPr>
       </a:lvl7pPr>
       <a:lvl8pPr xmlns:a="http://schemas.openxmlformats.org/drawingml/2006/main" marL="3200400" algn="l">
@@ -841,9 +841,9 @@
           <a:solidFill>
             <a:schemeClr val="tx1"/>
           </a:solidFill>
-          <a:latin typeface="+mn-lt"/>
-          <a:ea typeface="+mn-lt"/>
-          <a:cs typeface="+mn-lt"/>
+          <a:latin typeface="Alibaba PuHuiTi"/>
+          <a:ea typeface="Alibaba PuHuiTi"/>
+          <a:cs typeface="Alibaba PuHuiTi"/>
         </a:defRPr>
       </a:lvl8pPr>
       <a:lvl9pPr xmlns:a="http://schemas.openxmlformats.org/drawingml/2006/main" marL="3657600" algn="l">
@@ -852,9 +852,9 @@
           <a:solidFill>
             <a:schemeClr val="tx1"/>
           </a:solidFill>
-          <a:latin typeface="+mn-lt"/>
-          <a:ea typeface="+mn-lt"/>
-          <a:cs typeface="+mn-lt"/>
+          <a:latin typeface="Alibaba PuHuiTi"/>
+          <a:ea typeface="Alibaba PuHuiTi"/>
+          <a:cs typeface="Alibaba PuHuiTi"/>
         </a:defRPr>
       </a:lvl9pPr>
     </p:otherStyle>
@@ -905,14 +905,14 @@
     </a:clrScheme>
     <a:fontScheme name="Office">
       <a:majorFont>
-        <a:latin typeface="Calibri Light"/>
-        <a:ea typeface="Calibri Light"/>
-        <a:cs typeface="Calibri Light"/>
+        <a:latin typeface="Alibaba PuHuiTi"/>
+        <a:ea typeface="Alibaba PuHuiTi"/>
+        <a:cs typeface="Alibaba PuHuiTi"/>
       </a:majorFont>
       <a:minorFont>
-        <a:latin typeface="Calibri"/>
-        <a:ea typeface="Calibri"/>
-        <a:cs typeface="Calibri"/>
+        <a:latin typeface="Alibaba PuHuiTi"/>
+        <a:ea typeface="Alibaba PuHuiTi"/>
+        <a:cs typeface="Alibaba PuHuiTi"/>
       </a:minorFont>
     </a:fontScheme>
     <a:fmtScheme name="ChatGPT">
@@ -1159,13 +1159,14 @@
           <a:lstStyle xmlns:a="http://schemas.openxmlformats.org/drawingml/2006/main"/>
           <a:p xmlns:a="http://schemas.openxmlformats.org/drawingml/2006/main">
             <a:pPr algn="l">
+              <a:buNone/>
               <a:defRPr sz="3600" b="1">
                 <a:solidFill>
                   <a:srgbClr val="101216"/>
                 </a:solidFill>
-                <a:latin typeface="PingFang SC"/>
-                <a:ea typeface="PingFang SC"/>
-                <a:cs typeface="PingFang SC"/>
+                <a:latin typeface="Alibaba PuHuiTi"/>
+                <a:ea typeface="Alibaba PuHuiTi"/>
+                <a:cs typeface="Alibaba PuHuiTi"/>
               </a:defRPr>
             </a:pPr>
             <a:r>
@@ -1173,9 +1174,9 @@
                 <a:solidFill>
                   <a:srgbClr val="101216"/>
                 </a:solidFill>
-                <a:latin typeface="PingFang SC"/>
-                <a:ea typeface="PingFang SC"/>
-                <a:cs typeface="PingFang SC"/>
+                <a:latin typeface="Alibaba PuHuiTi"/>
+                <a:ea typeface="Alibaba PuHuiTi"/>
+                <a:cs typeface="Alibaba PuHuiTi"/>
               </a:rPr>
               <a:t>Awesome 仓库开始被 agent 直接使用</a:t>
             </a:r>
@@ -1215,13 +1216,14 @@
           <a:lstStyle xmlns:a="http://schemas.openxmlformats.org/drawingml/2006/main"/>
           <a:p xmlns:a="http://schemas.openxmlformats.org/drawingml/2006/main">
             <a:pPr algn="l">
+              <a:buNone/>
               <a:defRPr sz="1575" b="0">
                 <a:solidFill>
                   <a:srgbClr val="545B65"/>
                 </a:solidFill>
-                <a:latin typeface="PingFang SC"/>
-                <a:ea typeface="PingFang SC"/>
-                <a:cs typeface="PingFang SC"/>
+                <a:latin typeface="Alibaba PuHuiTi"/>
+                <a:ea typeface="Alibaba PuHuiTi"/>
+                <a:cs typeface="Alibaba PuHuiTi"/>
               </a:defRPr>
             </a:pPr>
             <a:r>
@@ -1229,9 +1231,9 @@
                 <a:solidFill>
                   <a:srgbClr val="545B65"/>
                 </a:solidFill>
-                <a:latin typeface="PingFang SC"/>
-                <a:ea typeface="PingFang SC"/>
-                <a:cs typeface="PingFang SC"/>
+                <a:latin typeface="Alibaba PuHuiTi"/>
+                <a:ea typeface="Alibaba PuHuiTi"/>
+                <a:cs typeface="Alibaba PuHuiTi"/>
               </a:rPr>
               <a:t>8 个项目，看看一份“清单”怎样逐渐变成文件、安装入口和工作方法</a:t>
             </a:r>
@@ -1337,13 +1339,14 @@
           <a:lstStyle xmlns:a="http://schemas.openxmlformats.org/drawingml/2006/main"/>
           <a:p xmlns:a="http://schemas.openxmlformats.org/drawingml/2006/main">
             <a:pPr algn="l">
+              <a:buNone/>
               <a:defRPr sz="2025" b="1">
                 <a:solidFill>
                   <a:srgbClr val="101216"/>
                 </a:solidFill>
-                <a:latin typeface="PingFang SC"/>
-                <a:ea typeface="PingFang SC"/>
-                <a:cs typeface="PingFang SC"/>
+                <a:latin typeface="Alibaba PuHuiTi"/>
+                <a:ea typeface="Alibaba PuHuiTi"/>
+                <a:cs typeface="Alibaba PuHuiTi"/>
               </a:defRPr>
             </a:pPr>
             <a:r>
@@ -1351,9 +1354,9 @@
                 <a:solidFill>
                   <a:srgbClr val="101216"/>
                 </a:solidFill>
-                <a:latin typeface="PingFang SC"/>
-                <a:ea typeface="PingFang SC"/>
-                <a:cs typeface="PingFang SC"/>
+                <a:latin typeface="Alibaba PuHuiTi"/>
+                <a:ea typeface="Alibaba PuHuiTi"/>
+                <a:cs typeface="Alibaba PuHuiTi"/>
               </a:rPr>
               <a:t>01  DISCOVER</a:t>
             </a:r>
@@ -1393,13 +1396,14 @@
           <a:lstStyle xmlns:a="http://schemas.openxmlformats.org/drawingml/2006/main"/>
           <a:p xmlns:a="http://schemas.openxmlformats.org/drawingml/2006/main">
             <a:pPr algn="l">
+              <a:buNone/>
               <a:defRPr sz="1350" b="0">
                 <a:solidFill>
                   <a:srgbClr val="101216"/>
                 </a:solidFill>
-                <a:latin typeface="PingFang SC"/>
-                <a:ea typeface="PingFang SC"/>
-                <a:cs typeface="PingFang SC"/>
+                <a:latin typeface="Alibaba PuHuiTi"/>
+                <a:ea typeface="Alibaba PuHuiTi"/>
+                <a:cs typeface="Alibaba PuHuiTi"/>
               </a:defRPr>
             </a:pPr>
             <a:r>
@@ -1407,9 +1411,9 @@
                 <a:solidFill>
                   <a:srgbClr val="101216"/>
                 </a:solidFill>
-                <a:latin typeface="PingFang SC"/>
-                <a:ea typeface="PingFang SC"/>
-                <a:cs typeface="PingFang SC"/>
+                <a:latin typeface="Alibaba PuHuiTi"/>
+                <a:ea typeface="Alibaba PuHuiTi"/>
+                <a:cs typeface="Alibaba PuHuiTi"/>
               </a:rPr>
               <a:t>人来读，自己挑</a:t>
             </a:r>
@@ -1449,13 +1453,14 @@
           <a:lstStyle xmlns:a="http://schemas.openxmlformats.org/drawingml/2006/main"/>
           <a:p xmlns:a="http://schemas.openxmlformats.org/drawingml/2006/main">
             <a:pPr algn="l">
+              <a:buNone/>
               <a:defRPr sz="1950" b="1">
                 <a:solidFill>
                   <a:srgbClr val="101216"/>
                 </a:solidFill>
-                <a:latin typeface="PingFang SC"/>
-                <a:ea typeface="PingFang SC"/>
-                <a:cs typeface="PingFang SC"/>
+                <a:latin typeface="Alibaba PuHuiTi"/>
+                <a:ea typeface="Alibaba PuHuiTi"/>
+                <a:cs typeface="Alibaba PuHuiTi"/>
               </a:defRPr>
             </a:pPr>
             <a:r>
@@ -1463,9 +1468,9 @@
                 <a:solidFill>
                   <a:srgbClr val="101216"/>
                 </a:solidFill>
-                <a:latin typeface="PingFang SC"/>
-                <a:ea typeface="PingFang SC"/>
-                <a:cs typeface="PingFang SC"/>
+                <a:latin typeface="Alibaba PuHuiTi"/>
+                <a:ea typeface="Alibaba PuHuiTi"/>
+                <a:cs typeface="Alibaba PuHuiTi"/>
               </a:rPr>
               <a:t>awesome</a:t>
             </a:r>
@@ -1505,13 +1510,14 @@
           <a:lstStyle xmlns:a="http://schemas.openxmlformats.org/drawingml/2006/main"/>
           <a:p xmlns:a="http://schemas.openxmlformats.org/drawingml/2006/main">
             <a:pPr algn="l">
+              <a:buNone/>
               <a:defRPr sz="1125" b="0">
                 <a:solidFill>
                   <a:srgbClr val="545B65"/>
                 </a:solidFill>
-                <a:latin typeface="PingFang SC"/>
-                <a:ea typeface="PingFang SC"/>
-                <a:cs typeface="PingFang SC"/>
+                <a:latin typeface="Alibaba PuHuiTi"/>
+                <a:ea typeface="Alibaba PuHuiTi"/>
+                <a:cs typeface="Alibaba PuHuiTi"/>
               </a:defRPr>
             </a:pPr>
             <a:r>
@@ -1519,9 +1525,9 @@
                 <a:solidFill>
                   <a:srgbClr val="545B65"/>
                 </a:solidFill>
-                <a:latin typeface="PingFang SC"/>
-                <a:ea typeface="PingFang SC"/>
-                <a:cs typeface="PingFang SC"/>
+                <a:latin typeface="Alibaba PuHuiTi"/>
+                <a:ea typeface="Alibaba PuHuiTi"/>
+                <a:cs typeface="Alibaba PuHuiTi"/>
               </a:rPr>
               <a:t>sindresorhus</a:t>
             </a:r>
@@ -1561,13 +1567,14 @@
           <a:lstStyle xmlns:a="http://schemas.openxmlformats.org/drawingml/2006/main"/>
           <a:p xmlns:a="http://schemas.openxmlformats.org/drawingml/2006/main">
             <a:pPr algn="l">
+              <a:buNone/>
               <a:defRPr sz="1500" b="0">
                 <a:solidFill>
                   <a:srgbClr val="545B65"/>
                 </a:solidFill>
-                <a:latin typeface="PingFang SC"/>
-                <a:ea typeface="PingFang SC"/>
-                <a:cs typeface="PingFang SC"/>
+                <a:latin typeface="Alibaba PuHuiTi"/>
+                <a:ea typeface="Alibaba PuHuiTi"/>
+                <a:cs typeface="Alibaba PuHuiTi"/>
               </a:defRPr>
             </a:pPr>
             <a:r>
@@ -1575,9 +1582,9 @@
                 <a:solidFill>
                   <a:srgbClr val="545B65"/>
                 </a:solidFill>
-                <a:latin typeface="PingFang SC"/>
-                <a:ea typeface="PingFang SC"/>
-                <a:cs typeface="PingFang SC"/>
+                <a:latin typeface="Alibaba PuHuiTi"/>
+                <a:ea typeface="Alibaba PuHuiTi"/>
+                <a:cs typeface="Alibaba PuHuiTi"/>
               </a:rPr>
               <a:t>经典元目录。人按主题浏览，再进入下一份列表。</a:t>
             </a:r>
@@ -1650,13 +1657,14 @@
           <a:lstStyle xmlns:a="http://schemas.openxmlformats.org/drawingml/2006/main"/>
           <a:p xmlns:a="http://schemas.openxmlformats.org/drawingml/2006/main">
             <a:pPr algn="l">
+              <a:buNone/>
               <a:defRPr sz="1575" b="1">
                 <a:solidFill>
                   <a:srgbClr val="101216"/>
                 </a:solidFill>
-                <a:latin typeface="PingFang SC"/>
-                <a:ea typeface="PingFang SC"/>
-                <a:cs typeface="PingFang SC"/>
+                <a:latin typeface="Alibaba PuHuiTi"/>
+                <a:ea typeface="Alibaba PuHuiTi"/>
+                <a:cs typeface="Alibaba PuHuiTi"/>
               </a:defRPr>
             </a:pPr>
             <a:r>
@@ -1664,9 +1672,9 @@
                 <a:solidFill>
                   <a:srgbClr val="101216"/>
                 </a:solidFill>
-                <a:latin typeface="PingFang SC"/>
-                <a:ea typeface="PingFang SC"/>
-                <a:cs typeface="PingFang SC"/>
+                <a:latin typeface="Alibaba PuHuiTi"/>
+                <a:ea typeface="Alibaba PuHuiTi"/>
+                <a:cs typeface="Alibaba PuHuiTi"/>
               </a:rPr>
               <a:t>awesome-mcp-servers</a:t>
             </a:r>
@@ -1706,13 +1714,14 @@
           <a:lstStyle xmlns:a="http://schemas.openxmlformats.org/drawingml/2006/main"/>
           <a:p xmlns:a="http://schemas.openxmlformats.org/drawingml/2006/main">
             <a:pPr algn="l">
+              <a:buNone/>
               <a:defRPr sz="1125" b="0">
                 <a:solidFill>
                   <a:srgbClr val="545B65"/>
                 </a:solidFill>
-                <a:latin typeface="PingFang SC"/>
-                <a:ea typeface="PingFang SC"/>
-                <a:cs typeface="PingFang SC"/>
+                <a:latin typeface="Alibaba PuHuiTi"/>
+                <a:ea typeface="Alibaba PuHuiTi"/>
+                <a:cs typeface="Alibaba PuHuiTi"/>
               </a:defRPr>
             </a:pPr>
             <a:r>
@@ -1720,9 +1729,9 @@
                 <a:solidFill>
                   <a:srgbClr val="545B65"/>
                 </a:solidFill>
-                <a:latin typeface="PingFang SC"/>
-                <a:ea typeface="PingFang SC"/>
-                <a:cs typeface="PingFang SC"/>
+                <a:latin typeface="Alibaba PuHuiTi"/>
+                <a:ea typeface="Alibaba PuHuiTi"/>
+                <a:cs typeface="Alibaba PuHuiTi"/>
               </a:rPr>
               <a:t>punkpeye</a:t>
             </a:r>
@@ -1762,13 +1771,14 @@
           <a:lstStyle xmlns:a="http://schemas.openxmlformats.org/drawingml/2006/main"/>
           <a:p xmlns:a="http://schemas.openxmlformats.org/drawingml/2006/main">
             <a:pPr algn="l">
+              <a:buNone/>
               <a:defRPr sz="1500" b="0">
                 <a:solidFill>
                   <a:srgbClr val="545B65"/>
                 </a:solidFill>
-                <a:latin typeface="PingFang SC"/>
-                <a:ea typeface="PingFang SC"/>
-                <a:cs typeface="PingFang SC"/>
+                <a:latin typeface="Alibaba PuHuiTi"/>
+                <a:ea typeface="Alibaba PuHuiTi"/>
+                <a:cs typeface="Alibaba PuHuiTi"/>
               </a:defRPr>
             </a:pPr>
             <a:r>
@@ -1776,9 +1786,9 @@
                 <a:solidFill>
                   <a:srgbClr val="545B65"/>
                 </a:solidFill>
-                <a:latin typeface="PingFang SC"/>
-                <a:ea typeface="PingFang SC"/>
-                <a:cs typeface="PingFang SC"/>
+                <a:latin typeface="Alibaba PuHuiTi"/>
+                <a:ea typeface="Alibaba PuHuiTi"/>
+                <a:cs typeface="Alibaba PuHuiTi"/>
               </a:rPr>
               <a:t>收集 MCP servers，帮人找到 agent 能调用的数据源和工具。</a:t>
             </a:r>
@@ -1851,13 +1861,14 @@
           <a:lstStyle xmlns:a="http://schemas.openxmlformats.org/drawingml/2006/main"/>
           <a:p xmlns:a="http://schemas.openxmlformats.org/drawingml/2006/main">
             <a:pPr algn="l">
+              <a:buNone/>
               <a:defRPr sz="2025" b="1">
                 <a:solidFill>
                   <a:srgbClr val="101216"/>
                 </a:solidFill>
-                <a:latin typeface="PingFang SC"/>
-                <a:ea typeface="PingFang SC"/>
-                <a:cs typeface="PingFang SC"/>
+                <a:latin typeface="Alibaba PuHuiTi"/>
+                <a:ea typeface="Alibaba PuHuiTi"/>
+                <a:cs typeface="Alibaba PuHuiTi"/>
               </a:defRPr>
             </a:pPr>
             <a:r>
@@ -1865,9 +1876,9 @@
                 <a:solidFill>
                   <a:srgbClr val="101216"/>
                 </a:solidFill>
-                <a:latin typeface="PingFang SC"/>
-                <a:ea typeface="PingFang SC"/>
-                <a:cs typeface="PingFang SC"/>
+                <a:latin typeface="Alibaba PuHuiTi"/>
+                <a:ea typeface="Alibaba PuHuiTi"/>
+                <a:cs typeface="Alibaba PuHuiTi"/>
               </a:rPr>
               <a:t>02  REUSE</a:t>
             </a:r>
@@ -1907,13 +1918,14 @@
           <a:lstStyle xmlns:a="http://schemas.openxmlformats.org/drawingml/2006/main"/>
           <a:p xmlns:a="http://schemas.openxmlformats.org/drawingml/2006/main">
             <a:pPr algn="l">
+              <a:buNone/>
               <a:defRPr sz="1350" b="0">
                 <a:solidFill>
                   <a:srgbClr val="101216"/>
                 </a:solidFill>
-                <a:latin typeface="PingFang SC"/>
-                <a:ea typeface="PingFang SC"/>
-                <a:cs typeface="PingFang SC"/>
+                <a:latin typeface="Alibaba PuHuiTi"/>
+                <a:ea typeface="Alibaba PuHuiTi"/>
+                <a:cs typeface="Alibaba PuHuiTi"/>
               </a:defRPr>
             </a:pPr>
             <a:r>
@@ -1921,9 +1933,9 @@
                 <a:solidFill>
                   <a:srgbClr val="101216"/>
                 </a:solidFill>
-                <a:latin typeface="PingFang SC"/>
-                <a:ea typeface="PingFang SC"/>
-                <a:cs typeface="PingFang SC"/>
+                <a:latin typeface="Alibaba PuHuiTi"/>
+                <a:ea typeface="Alibaba PuHuiTi"/>
+                <a:cs typeface="Alibaba PuHuiTi"/>
               </a:rPr>
               <a:t>拿走一份文件</a:t>
             </a:r>
@@ -1963,13 +1975,14 @@
           <a:lstStyle xmlns:a="http://schemas.openxmlformats.org/drawingml/2006/main"/>
           <a:p xmlns:a="http://schemas.openxmlformats.org/drawingml/2006/main">
             <a:pPr algn="l">
+              <a:buNone/>
               <a:defRPr sz="1650" b="1">
                 <a:solidFill>
                   <a:srgbClr val="101216"/>
                 </a:solidFill>
-                <a:latin typeface="PingFang SC"/>
-                <a:ea typeface="PingFang SC"/>
-                <a:cs typeface="PingFang SC"/>
+                <a:latin typeface="Alibaba PuHuiTi"/>
+                <a:ea typeface="Alibaba PuHuiTi"/>
+                <a:cs typeface="Alibaba PuHuiTi"/>
               </a:defRPr>
             </a:pPr>
             <a:r>
@@ -1977,9 +1990,9 @@
                 <a:solidFill>
                   <a:srgbClr val="101216"/>
                 </a:solidFill>
-                <a:latin typeface="PingFang SC"/>
-                <a:ea typeface="PingFang SC"/>
-                <a:cs typeface="PingFang SC"/>
+                <a:latin typeface="Alibaba PuHuiTi"/>
+                <a:ea typeface="Alibaba PuHuiTi"/>
+                <a:cs typeface="Alibaba PuHuiTi"/>
               </a:rPr>
               <a:t>awesome-design-md</a:t>
             </a:r>
@@ -2019,13 +2032,14 @@
           <a:lstStyle xmlns:a="http://schemas.openxmlformats.org/drawingml/2006/main"/>
           <a:p xmlns:a="http://schemas.openxmlformats.org/drawingml/2006/main">
             <a:pPr algn="l">
+              <a:buNone/>
               <a:defRPr sz="1125" b="0">
                 <a:solidFill>
                   <a:srgbClr val="545B65"/>
                 </a:solidFill>
-                <a:latin typeface="PingFang SC"/>
-                <a:ea typeface="PingFang SC"/>
-                <a:cs typeface="PingFang SC"/>
+                <a:latin typeface="Alibaba PuHuiTi"/>
+                <a:ea typeface="Alibaba PuHuiTi"/>
+                <a:cs typeface="Alibaba PuHuiTi"/>
               </a:defRPr>
             </a:pPr>
             <a:r>
@@ -2033,9 +2047,9 @@
                 <a:solidFill>
                   <a:srgbClr val="545B65"/>
                 </a:solidFill>
-                <a:latin typeface="PingFang SC"/>
-                <a:ea typeface="PingFang SC"/>
-                <a:cs typeface="PingFang SC"/>
+                <a:latin typeface="Alibaba PuHuiTi"/>
+                <a:ea typeface="Alibaba PuHuiTi"/>
+                <a:cs typeface="Alibaba PuHuiTi"/>
               </a:rPr>
               <a:t>VoltAgent</a:t>
             </a:r>
@@ -2075,13 +2089,14 @@
           <a:lstStyle xmlns:a="http://schemas.openxmlformats.org/drawingml/2006/main"/>
           <a:p xmlns:a="http://schemas.openxmlformats.org/drawingml/2006/main">
             <a:pPr algn="l">
+              <a:buNone/>
               <a:defRPr sz="1500" b="0">
                 <a:solidFill>
                   <a:srgbClr val="545B65"/>
                 </a:solidFill>
-                <a:latin typeface="PingFang SC"/>
-                <a:ea typeface="PingFang SC"/>
-                <a:cs typeface="PingFang SC"/>
+                <a:latin typeface="Alibaba PuHuiTi"/>
+                <a:ea typeface="Alibaba PuHuiTi"/>
+                <a:cs typeface="Alibaba PuHuiTi"/>
               </a:defRPr>
             </a:pPr>
             <a:r>
@@ -2089,9 +2104,9 @@
                 <a:solidFill>
                   <a:srgbClr val="545B65"/>
                 </a:solidFill>
-                <a:latin typeface="PingFang SC"/>
-                <a:ea typeface="PingFang SC"/>
-                <a:cs typeface="PingFang SC"/>
+                <a:latin typeface="Alibaba PuHuiTi"/>
+                <a:ea typeface="Alibaba PuHuiTi"/>
+                <a:cs typeface="Alibaba PuHuiTi"/>
               </a:rPr>
               <a:t>把网站设计规则写进 DESIGN.md，coding agent 拿来就能做 UI。</a:t>
             </a:r>
@@ -2164,13 +2179,14 @@
           <a:lstStyle xmlns:a="http://schemas.openxmlformats.org/drawingml/2006/main"/>
           <a:p xmlns:a="http://schemas.openxmlformats.org/drawingml/2006/main">
             <a:pPr algn="l">
+              <a:buNone/>
               <a:defRPr sz="1575" b="1">
                 <a:solidFill>
                   <a:srgbClr val="101216"/>
                 </a:solidFill>
-                <a:latin typeface="PingFang SC"/>
-                <a:ea typeface="PingFang SC"/>
-                <a:cs typeface="PingFang SC"/>
+                <a:latin typeface="Alibaba PuHuiTi"/>
+                <a:ea typeface="Alibaba PuHuiTi"/>
+                <a:cs typeface="Alibaba PuHuiTi"/>
               </a:defRPr>
             </a:pPr>
             <a:r>
@@ -2178,9 +2194,9 @@
                 <a:solidFill>
                   <a:srgbClr val="101216"/>
                 </a:solidFill>
-                <a:latin typeface="PingFang SC"/>
-                <a:ea typeface="PingFang SC"/>
-                <a:cs typeface="PingFang SC"/>
+                <a:latin typeface="Alibaba PuHuiTi"/>
+                <a:ea typeface="Alibaba PuHuiTi"/>
+                <a:cs typeface="Alibaba PuHuiTi"/>
               </a:rPr>
               <a:t>awesome-gpt-image-2</a:t>
             </a:r>
@@ -2220,13 +2236,14 @@
           <a:lstStyle xmlns:a="http://schemas.openxmlformats.org/drawingml/2006/main"/>
           <a:p xmlns:a="http://schemas.openxmlformats.org/drawingml/2006/main">
             <a:pPr algn="l">
+              <a:buNone/>
               <a:defRPr sz="1125" b="0">
                 <a:solidFill>
                   <a:srgbClr val="545B65"/>
                 </a:solidFill>
-                <a:latin typeface="PingFang SC"/>
-                <a:ea typeface="PingFang SC"/>
-                <a:cs typeface="PingFang SC"/>
+                <a:latin typeface="Alibaba PuHuiTi"/>
+                <a:ea typeface="Alibaba PuHuiTi"/>
+                <a:cs typeface="Alibaba PuHuiTi"/>
               </a:defRPr>
             </a:pPr>
             <a:r>
@@ -2234,9 +2251,9 @@
                 <a:solidFill>
                   <a:srgbClr val="545B65"/>
                 </a:solidFill>
-                <a:latin typeface="PingFang SC"/>
-                <a:ea typeface="PingFang SC"/>
-                <a:cs typeface="PingFang SC"/>
+                <a:latin typeface="Alibaba PuHuiTi"/>
+                <a:ea typeface="Alibaba PuHuiTi"/>
+                <a:cs typeface="Alibaba PuHuiTi"/>
               </a:rPr>
               <a:t>freestylefly</a:t>
             </a:r>
@@ -2276,13 +2293,14 @@
           <a:lstStyle xmlns:a="http://schemas.openxmlformats.org/drawingml/2006/main"/>
           <a:p xmlns:a="http://schemas.openxmlformats.org/drawingml/2006/main">
             <a:pPr algn="l">
+              <a:buNone/>
               <a:defRPr sz="1500" b="0">
                 <a:solidFill>
                   <a:srgbClr val="545B65"/>
                 </a:solidFill>
-                <a:latin typeface="PingFang SC"/>
-                <a:ea typeface="PingFang SC"/>
-                <a:cs typeface="PingFang SC"/>
+                <a:latin typeface="Alibaba PuHuiTi"/>
+                <a:ea typeface="Alibaba PuHuiTi"/>
+                <a:cs typeface="Alibaba PuHuiTi"/>
               </a:defRPr>
             </a:pPr>
             <a:r>
@@ -2290,9 +2308,9 @@
                 <a:solidFill>
                   <a:srgbClr val="545B65"/>
                 </a:solidFill>
-                <a:latin typeface="PingFang SC"/>
-                <a:ea typeface="PingFang SC"/>
-                <a:cs typeface="PingFang SC"/>
+                <a:latin typeface="Alibaba PuHuiTi"/>
+                <a:ea typeface="Alibaba PuHuiTi"/>
+                <a:cs typeface="Alibaba PuHuiTi"/>
               </a:rPr>
               <a:t>案例和模板共用一份 style library，并生成可安装的 agent skill。</a:t>
             </a:r>
@@ -2365,13 +2383,14 @@
           <a:lstStyle xmlns:a="http://schemas.openxmlformats.org/drawingml/2006/main"/>
           <a:p xmlns:a="http://schemas.openxmlformats.org/drawingml/2006/main">
             <a:pPr algn="l">
+              <a:buNone/>
               <a:defRPr sz="2025" b="1">
                 <a:solidFill>
                   <a:srgbClr val="101216"/>
                 </a:solidFill>
-                <a:latin typeface="PingFang SC"/>
-                <a:ea typeface="PingFang SC"/>
-                <a:cs typeface="PingFang SC"/>
+                <a:latin typeface="Alibaba PuHuiTi"/>
+                <a:ea typeface="Alibaba PuHuiTi"/>
+                <a:cs typeface="Alibaba PuHuiTi"/>
               </a:defRPr>
             </a:pPr>
             <a:r>
@@ -2379,9 +2398,9 @@
                 <a:solidFill>
                   <a:srgbClr val="101216"/>
                 </a:solidFill>
-                <a:latin typeface="PingFang SC"/>
-                <a:ea typeface="PingFang SC"/>
-                <a:cs typeface="PingFang SC"/>
+                <a:latin typeface="Alibaba PuHuiTi"/>
+                <a:ea typeface="Alibaba PuHuiTi"/>
+                <a:cs typeface="Alibaba PuHuiTi"/>
               </a:rPr>
               <a:t>03  INSTALL</a:t>
             </a:r>
@@ -2421,13 +2440,14 @@
           <a:lstStyle xmlns:a="http://schemas.openxmlformats.org/drawingml/2006/main"/>
           <a:p xmlns:a="http://schemas.openxmlformats.org/drawingml/2006/main">
             <a:pPr algn="l">
+              <a:buNone/>
               <a:defRPr sz="1350" b="0">
                 <a:solidFill>
                   <a:srgbClr val="101216"/>
                 </a:solidFill>
-                <a:latin typeface="PingFang SC"/>
-                <a:ea typeface="PingFang SC"/>
-                <a:cs typeface="PingFang SC"/>
+                <a:latin typeface="Alibaba PuHuiTi"/>
+                <a:ea typeface="Alibaba PuHuiTi"/>
+                <a:cs typeface="Alibaba PuHuiTi"/>
               </a:defRPr>
             </a:pPr>
             <a:r>
@@ -2435,9 +2455,9 @@
                 <a:solidFill>
                   <a:srgbClr val="101216"/>
                 </a:solidFill>
-                <a:latin typeface="PingFang SC"/>
-                <a:ea typeface="PingFang SC"/>
-                <a:cs typeface="PingFang SC"/>
+                <a:latin typeface="Alibaba PuHuiTi"/>
+                <a:ea typeface="Alibaba PuHuiTi"/>
+                <a:cs typeface="Alibaba PuHuiTi"/>
               </a:rPr>
               <a:t>交给工具安装</a:t>
             </a:r>
@@ -2477,13 +2497,14 @@
           <a:lstStyle xmlns:a="http://schemas.openxmlformats.org/drawingml/2006/main"/>
           <a:p xmlns:a="http://schemas.openxmlformats.org/drawingml/2006/main">
             <a:pPr algn="l">
+              <a:buNone/>
               <a:defRPr sz="1950" b="1">
                 <a:solidFill>
                   <a:srgbClr val="101216"/>
                 </a:solidFill>
-                <a:latin typeface="PingFang SC"/>
-                <a:ea typeface="PingFang SC"/>
-                <a:cs typeface="PingFang SC"/>
+                <a:latin typeface="Alibaba PuHuiTi"/>
+                <a:ea typeface="Alibaba PuHuiTi"/>
+                <a:cs typeface="Alibaba PuHuiTi"/>
               </a:defRPr>
             </a:pPr>
             <a:r>
@@ -2491,9 +2512,9 @@
                 <a:solidFill>
                   <a:srgbClr val="101216"/>
                 </a:solidFill>
-                <a:latin typeface="PingFang SC"/>
-                <a:ea typeface="PingFang SC"/>
-                <a:cs typeface="PingFang SC"/>
+                <a:latin typeface="Alibaba PuHuiTi"/>
+                <a:ea typeface="Alibaba PuHuiTi"/>
+                <a:cs typeface="Alibaba PuHuiTi"/>
               </a:rPr>
               <a:t>skills</a:t>
             </a:r>
@@ -2533,13 +2554,14 @@
           <a:lstStyle xmlns:a="http://schemas.openxmlformats.org/drawingml/2006/main"/>
           <a:p xmlns:a="http://schemas.openxmlformats.org/drawingml/2006/main">
             <a:pPr algn="l">
+              <a:buNone/>
               <a:defRPr sz="1125" b="0">
                 <a:solidFill>
                   <a:srgbClr val="545B65"/>
                 </a:solidFill>
-                <a:latin typeface="PingFang SC"/>
-                <a:ea typeface="PingFang SC"/>
-                <a:cs typeface="PingFang SC"/>
+                <a:latin typeface="Alibaba PuHuiTi"/>
+                <a:ea typeface="Alibaba PuHuiTi"/>
+                <a:cs typeface="Alibaba PuHuiTi"/>
               </a:defRPr>
             </a:pPr>
             <a:r>
@@ -2547,9 +2569,9 @@
                 <a:solidFill>
                   <a:srgbClr val="545B65"/>
                 </a:solidFill>
-                <a:latin typeface="PingFang SC"/>
-                <a:ea typeface="PingFang SC"/>
-                <a:cs typeface="PingFang SC"/>
+                <a:latin typeface="Alibaba PuHuiTi"/>
+                <a:ea typeface="Alibaba PuHuiTi"/>
+                <a:cs typeface="Alibaba PuHuiTi"/>
               </a:rPr>
               <a:t>vercel-labs</a:t>
             </a:r>
@@ -2589,13 +2611,14 @@
           <a:lstStyle xmlns:a="http://schemas.openxmlformats.org/drawingml/2006/main"/>
           <a:p xmlns:a="http://schemas.openxmlformats.org/drawingml/2006/main">
             <a:pPr algn="l">
+              <a:buNone/>
               <a:defRPr sz="1500" b="0">
                 <a:solidFill>
                   <a:srgbClr val="545B65"/>
                 </a:solidFill>
-                <a:latin typeface="PingFang SC"/>
-                <a:ea typeface="PingFang SC"/>
-                <a:cs typeface="PingFang SC"/>
+                <a:latin typeface="Alibaba PuHuiTi"/>
+                <a:ea typeface="Alibaba PuHuiTi"/>
+                <a:cs typeface="Alibaba PuHuiTi"/>
               </a:defRPr>
             </a:pPr>
             <a:r>
@@ -2603,9 +2626,9 @@
                 <a:solidFill>
                   <a:srgbClr val="545B65"/>
                 </a:solidFill>
-                <a:latin typeface="PingFang SC"/>
-                <a:ea typeface="PingFang SC"/>
-                <a:cs typeface="PingFang SC"/>
+                <a:latin typeface="Alibaba PuHuiTi"/>
+                <a:ea typeface="Alibaba PuHuiTi"/>
+                <a:cs typeface="Alibaba PuHuiTi"/>
               </a:rPr>
               <a:t>用 npx 搜索、安装或运行 skill。列表有了包管理语义。</a:t>
             </a:r>
@@ -2678,13 +2701,14 @@
           <a:lstStyle xmlns:a="http://schemas.openxmlformats.org/drawingml/2006/main"/>
           <a:p xmlns:a="http://schemas.openxmlformats.org/drawingml/2006/main">
             <a:pPr algn="l">
+              <a:buNone/>
               <a:defRPr sz="1650" b="1">
                 <a:solidFill>
                   <a:srgbClr val="101216"/>
                 </a:solidFill>
-                <a:latin typeface="PingFang SC"/>
-                <a:ea typeface="PingFang SC"/>
-                <a:cs typeface="PingFang SC"/>
+                <a:latin typeface="Alibaba PuHuiTi"/>
+                <a:ea typeface="Alibaba PuHuiTi"/>
+                <a:cs typeface="Alibaba PuHuiTi"/>
               </a:defRPr>
             </a:pPr>
             <a:r>
@@ -2692,9 +2716,9 @@
                 <a:solidFill>
                   <a:srgbClr val="101216"/>
                 </a:solidFill>
-                <a:latin typeface="PingFang SC"/>
-                <a:ea typeface="PingFang SC"/>
-                <a:cs typeface="PingFang SC"/>
+                <a:latin typeface="Alibaba PuHuiTi"/>
+                <a:ea typeface="Alibaba PuHuiTi"/>
+                <a:cs typeface="Alibaba PuHuiTi"/>
               </a:rPr>
               <a:t>anthropics/skills</a:t>
             </a:r>
@@ -2734,13 +2758,14 @@
           <a:lstStyle xmlns:a="http://schemas.openxmlformats.org/drawingml/2006/main"/>
           <a:p xmlns:a="http://schemas.openxmlformats.org/drawingml/2006/main">
             <a:pPr algn="l">
+              <a:buNone/>
               <a:defRPr sz="1125" b="0">
                 <a:solidFill>
                   <a:srgbClr val="545B65"/>
                 </a:solidFill>
-                <a:latin typeface="PingFang SC"/>
-                <a:ea typeface="PingFang SC"/>
-                <a:cs typeface="PingFang SC"/>
+                <a:latin typeface="Alibaba PuHuiTi"/>
+                <a:ea typeface="Alibaba PuHuiTi"/>
+                <a:cs typeface="Alibaba PuHuiTi"/>
               </a:defRPr>
             </a:pPr>
             <a:r>
@@ -2748,9 +2773,9 @@
                 <a:solidFill>
                   <a:srgbClr val="545B65"/>
                 </a:solidFill>
-                <a:latin typeface="PingFang SC"/>
-                <a:ea typeface="PingFang SC"/>
-                <a:cs typeface="PingFang SC"/>
+                <a:latin typeface="Alibaba PuHuiTi"/>
+                <a:ea typeface="Alibaba PuHuiTi"/>
+                <a:cs typeface="Alibaba PuHuiTi"/>
               </a:rPr>
               <a:t>anthropics</a:t>
             </a:r>
@@ -2790,13 +2815,14 @@
           <a:lstStyle xmlns:a="http://schemas.openxmlformats.org/drawingml/2006/main"/>
           <a:p xmlns:a="http://schemas.openxmlformats.org/drawingml/2006/main">
             <a:pPr algn="l">
+              <a:buNone/>
               <a:defRPr sz="1500" b="0">
                 <a:solidFill>
                   <a:srgbClr val="545B65"/>
                 </a:solidFill>
-                <a:latin typeface="PingFang SC"/>
-                <a:ea typeface="PingFang SC"/>
-                <a:cs typeface="PingFang SC"/>
+                <a:latin typeface="Alibaba PuHuiTi"/>
+                <a:ea typeface="Alibaba PuHuiTi"/>
+                <a:cs typeface="Alibaba PuHuiTi"/>
               </a:defRPr>
             </a:pPr>
             <a:r>
@@ -2804,9 +2830,9 @@
                 <a:solidFill>
                   <a:srgbClr val="545B65"/>
                 </a:solidFill>
-                <a:latin typeface="PingFang SC"/>
-                <a:ea typeface="PingFang SC"/>
-                <a:cs typeface="PingFang SC"/>
+                <a:latin typeface="Alibaba PuHuiTi"/>
+                <a:ea typeface="Alibaba PuHuiTi"/>
+                <a:cs typeface="Alibaba PuHuiTi"/>
               </a:rPr>
               <a:t>官方样例与规范。每项能力都是含说明、脚本和资源的文件夹。</a:t>
             </a:r>
@@ -2879,13 +2905,14 @@
           <a:lstStyle xmlns:a="http://schemas.openxmlformats.org/drawingml/2006/main"/>
           <a:p xmlns:a="http://schemas.openxmlformats.org/drawingml/2006/main">
             <a:pPr algn="l">
+              <a:buNone/>
               <a:defRPr sz="2025" b="1">
                 <a:solidFill>
                   <a:srgbClr val="101216"/>
                 </a:solidFill>
-                <a:latin typeface="PingFang SC"/>
-                <a:ea typeface="PingFang SC"/>
-                <a:cs typeface="PingFang SC"/>
+                <a:latin typeface="Alibaba PuHuiTi"/>
+                <a:ea typeface="Alibaba PuHuiTi"/>
+                <a:cs typeface="Alibaba PuHuiTi"/>
               </a:defRPr>
             </a:pPr>
             <a:r>
@@ -2893,9 +2920,9 @@
                 <a:solidFill>
                   <a:srgbClr val="101216"/>
                 </a:solidFill>
-                <a:latin typeface="PingFang SC"/>
-                <a:ea typeface="PingFang SC"/>
-                <a:cs typeface="PingFang SC"/>
+                <a:latin typeface="Alibaba PuHuiTi"/>
+                <a:ea typeface="Alibaba PuHuiTi"/>
+                <a:cs typeface="Alibaba PuHuiTi"/>
               </a:rPr>
               <a:t>04  OPERATE</a:t>
             </a:r>
@@ -2935,13 +2962,14 @@
           <a:lstStyle xmlns:a="http://schemas.openxmlformats.org/drawingml/2006/main"/>
           <a:p xmlns:a="http://schemas.openxmlformats.org/drawingml/2006/main">
             <a:pPr algn="l">
+              <a:buNone/>
               <a:defRPr sz="1350" b="0">
                 <a:solidFill>
                   <a:srgbClr val="101216"/>
                 </a:solidFill>
-                <a:latin typeface="PingFang SC"/>
-                <a:ea typeface="PingFang SC"/>
-                <a:cs typeface="PingFang SC"/>
+                <a:latin typeface="Alibaba PuHuiTi"/>
+                <a:ea typeface="Alibaba PuHuiTi"/>
+                <a:cs typeface="Alibaba PuHuiTi"/>
               </a:defRPr>
             </a:pPr>
             <a:r>
@@ -2949,9 +2977,9 @@
                 <a:solidFill>
                   <a:srgbClr val="101216"/>
                 </a:solidFill>
-                <a:latin typeface="PingFang SC"/>
-                <a:ea typeface="PingFang SC"/>
-                <a:cs typeface="PingFang SC"/>
+                <a:latin typeface="Alibaba PuHuiTi"/>
+                <a:ea typeface="Alibaba PuHuiTi"/>
+                <a:cs typeface="Alibaba PuHuiTi"/>
               </a:rPr>
               <a:t>规定 agent 怎么做</a:t>
             </a:r>
@@ -2991,13 +3019,14 @@
           <a:lstStyle xmlns:a="http://schemas.openxmlformats.org/drawingml/2006/main"/>
           <a:p xmlns:a="http://schemas.openxmlformats.org/drawingml/2006/main">
             <a:pPr algn="l">
+              <a:buNone/>
               <a:defRPr sz="1950" b="1">
                 <a:solidFill>
                   <a:srgbClr val="101216"/>
                 </a:solidFill>
-                <a:latin typeface="PingFang SC"/>
-                <a:ea typeface="PingFang SC"/>
-                <a:cs typeface="PingFang SC"/>
+                <a:latin typeface="Alibaba PuHuiTi"/>
+                <a:ea typeface="Alibaba PuHuiTi"/>
+                <a:cs typeface="Alibaba PuHuiTi"/>
               </a:defRPr>
             </a:pPr>
             <a:r>
@@ -3005,9 +3034,9 @@
                 <a:solidFill>
                   <a:srgbClr val="101216"/>
                 </a:solidFill>
-                <a:latin typeface="PingFang SC"/>
-                <a:ea typeface="PingFang SC"/>
-                <a:cs typeface="PingFang SC"/>
+                <a:latin typeface="Alibaba PuHuiTi"/>
+                <a:ea typeface="Alibaba PuHuiTi"/>
+                <a:cs typeface="Alibaba PuHuiTi"/>
               </a:rPr>
               <a:t>superpowers</a:t>
             </a:r>
@@ -3047,13 +3076,14 @@
           <a:lstStyle xmlns:a="http://schemas.openxmlformats.org/drawingml/2006/main"/>
           <a:p xmlns:a="http://schemas.openxmlformats.org/drawingml/2006/main">
             <a:pPr algn="l">
+              <a:buNone/>
               <a:defRPr sz="1125" b="0">
                 <a:solidFill>
                   <a:srgbClr val="545B65"/>
                 </a:solidFill>
-                <a:latin typeface="PingFang SC"/>
-                <a:ea typeface="PingFang SC"/>
-                <a:cs typeface="PingFang SC"/>
+                <a:latin typeface="Alibaba PuHuiTi"/>
+                <a:ea typeface="Alibaba PuHuiTi"/>
+                <a:cs typeface="Alibaba PuHuiTi"/>
               </a:defRPr>
             </a:pPr>
             <a:r>
@@ -3061,9 +3091,9 @@
                 <a:solidFill>
                   <a:srgbClr val="545B65"/>
                 </a:solidFill>
-                <a:latin typeface="PingFang SC"/>
-                <a:ea typeface="PingFang SC"/>
-                <a:cs typeface="PingFang SC"/>
+                <a:latin typeface="Alibaba PuHuiTi"/>
+                <a:ea typeface="Alibaba PuHuiTi"/>
+                <a:cs typeface="Alibaba PuHuiTi"/>
               </a:rPr>
               <a:t>obra</a:t>
             </a:r>
@@ -3103,13 +3133,14 @@
           <a:lstStyle xmlns:a="http://schemas.openxmlformats.org/drawingml/2006/main"/>
           <a:p xmlns:a="http://schemas.openxmlformats.org/drawingml/2006/main">
             <a:pPr algn="l">
+              <a:buNone/>
               <a:defRPr sz="1500" b="0">
                 <a:solidFill>
                   <a:srgbClr val="545B65"/>
                 </a:solidFill>
-                <a:latin typeface="PingFang SC"/>
-                <a:ea typeface="PingFang SC"/>
-                <a:cs typeface="PingFang SC"/>
+                <a:latin typeface="Alibaba PuHuiTi"/>
+                <a:ea typeface="Alibaba PuHuiTi"/>
+                <a:cs typeface="Alibaba PuHuiTi"/>
               </a:defRPr>
             </a:pPr>
             <a:r>
@@ -3117,9 +3148,9 @@
                 <a:solidFill>
                   <a:srgbClr val="545B65"/>
                 </a:solidFill>
-                <a:latin typeface="PingFang SC"/>
-                <a:ea typeface="PingFang SC"/>
-                <a:cs typeface="PingFang SC"/>
+                <a:latin typeface="Alibaba PuHuiTi"/>
+                <a:ea typeface="Alibaba PuHuiTi"/>
+                <a:cs typeface="Alibaba PuHuiTi"/>
               </a:rPr>
               <a:t>把澄清需求、写计划、TDD 和评审做成自动触发的 skills。</a:t>
             </a:r>
@@ -3192,13 +3223,14 @@
           <a:lstStyle xmlns:a="http://schemas.openxmlformats.org/drawingml/2006/main"/>
           <a:p xmlns:a="http://schemas.openxmlformats.org/drawingml/2006/main">
             <a:pPr algn="l">
+              <a:buNone/>
               <a:defRPr sz="1950" b="1">
                 <a:solidFill>
                   <a:srgbClr val="101216"/>
                 </a:solidFill>
-                <a:latin typeface="PingFang SC"/>
-                <a:ea typeface="PingFang SC"/>
-                <a:cs typeface="PingFang SC"/>
+                <a:latin typeface="Alibaba PuHuiTi"/>
+                <a:ea typeface="Alibaba PuHuiTi"/>
+                <a:cs typeface="Alibaba PuHuiTi"/>
               </a:defRPr>
             </a:pPr>
             <a:r>
@@ -3206,9 +3238,9 @@
                 <a:solidFill>
                   <a:srgbClr val="101216"/>
                 </a:solidFill>
-                <a:latin typeface="PingFang SC"/>
-                <a:ea typeface="PingFang SC"/>
-                <a:cs typeface="PingFang SC"/>
+                <a:latin typeface="Alibaba PuHuiTi"/>
+                <a:ea typeface="Alibaba PuHuiTi"/>
+                <a:cs typeface="Alibaba PuHuiTi"/>
               </a:rPr>
               <a:t>spec-kit</a:t>
             </a:r>
@@ -3248,13 +3280,14 @@
           <a:lstStyle xmlns:a="http://schemas.openxmlformats.org/drawingml/2006/main"/>
           <a:p xmlns:a="http://schemas.openxmlformats.org/drawingml/2006/main">
             <a:pPr algn="l">
+              <a:buNone/>
               <a:defRPr sz="1125" b="0">
                 <a:solidFill>
                   <a:srgbClr val="545B65"/>
                 </a:solidFill>
-                <a:latin typeface="PingFang SC"/>
-                <a:ea typeface="PingFang SC"/>
-                <a:cs typeface="PingFang SC"/>
+                <a:latin typeface="Alibaba PuHuiTi"/>
+                <a:ea typeface="Alibaba PuHuiTi"/>
+                <a:cs typeface="Alibaba PuHuiTi"/>
               </a:defRPr>
             </a:pPr>
             <a:r>
@@ -3262,9 +3295,9 @@
                 <a:solidFill>
                   <a:srgbClr val="545B65"/>
                 </a:solidFill>
-                <a:latin typeface="PingFang SC"/>
-                <a:ea typeface="PingFang SC"/>
-                <a:cs typeface="PingFang SC"/>
+                <a:latin typeface="Alibaba PuHuiTi"/>
+                <a:ea typeface="Alibaba PuHuiTi"/>
+                <a:cs typeface="Alibaba PuHuiTi"/>
               </a:rPr>
               <a:t>github</a:t>
             </a:r>
@@ -3304,13 +3337,14 @@
           <a:lstStyle xmlns:a="http://schemas.openxmlformats.org/drawingml/2006/main"/>
           <a:p xmlns:a="http://schemas.openxmlformats.org/drawingml/2006/main">
             <a:pPr algn="l">
+              <a:buNone/>
               <a:defRPr sz="1500" b="0">
                 <a:solidFill>
                   <a:srgbClr val="545B65"/>
                 </a:solidFill>
-                <a:latin typeface="PingFang SC"/>
-                <a:ea typeface="PingFang SC"/>
-                <a:cs typeface="PingFang SC"/>
+                <a:latin typeface="Alibaba PuHuiTi"/>
+                <a:ea typeface="Alibaba PuHuiTi"/>
+                <a:cs typeface="Alibaba PuHuiTi"/>
               </a:defRPr>
             </a:pPr>
             <a:r>
@@ -3318,9 +3352,9 @@
                 <a:solidFill>
                   <a:srgbClr val="545B65"/>
                 </a:solidFill>
-                <a:latin typeface="PingFang SC"/>
-                <a:ea typeface="PingFang SC"/>
-                <a:cs typeface="PingFang SC"/>
+                <a:latin typeface="Alibaba PuHuiTi"/>
+                <a:ea typeface="Alibaba PuHuiTi"/>
+                <a:cs typeface="Alibaba PuHuiTi"/>
               </a:rPr>
               <a:t>先保存规格和验收条件，再让 agent 写代码。</a:t>
             </a:r>
@@ -3380,14 +3414,14 @@
     </a:clrScheme>
     <a:fontScheme name="Office">
       <a:majorFont>
-        <a:latin typeface="Calibri Light"/>
-        <a:ea typeface="Calibri Light"/>
-        <a:cs typeface="Calibri Light"/>
+        <a:latin typeface="Alibaba PuHuiTi"/>
+        <a:ea typeface="Alibaba PuHuiTi"/>
+        <a:cs typeface="Alibaba PuHuiTi"/>
       </a:majorFont>
       <a:minorFont>
-        <a:latin typeface="Calibri"/>
-        <a:ea typeface="Calibri"/>
-        <a:cs typeface="Calibri"/>
+        <a:latin typeface="Alibaba PuHuiTi"/>
+        <a:ea typeface="Alibaba PuHuiTi"/>
+        <a:cs typeface="Alibaba PuHuiTi"/>
       </a:minorFont>
     </a:fontScheme>
     <a:fmtScheme name="ChatGPT">

</xml_diff>